<commit_message>
Ship the high-tech manufacturing playbook and retire the placeholder industries
The site now carries exactly two playbooks: the generic one and the new
high-tech manufacturing (advanced packaging) one. Both are fully built out
in all three languages - handbook, offline packs and deck.

High-tech manufacturing is new: six scenarios, 29 steps, 87 screenshots shot
on a live tenant, 72 sample files, and a 24-page deck per language.

The five remaining industries were placeholders that never had content behind
the Coming Soon card, so their handbooks, offline packs, decks and sample
folders are gone rather than left as dead weight.

The generic decks change too. They are rebuilt with the shared builder, which
fixes overlapping text on the scenario overview slide that the old hardcoded
layout produced.

Co-authored-by: Copilot <223556219+Copilot@users.noreply.github.com>
</commit_message>
<xml_diff>
--- a/CoworkPlaybook/CoworkPlaybook_Generic_en.pptx
+++ b/CoworkPlaybook/CoworkPlaybook_Generic_en.pptx
@@ -3190,7 +3190,7 @@
       </p:sp>
       <p:pic>
         <p:nvPicPr>
-          <p:cNvPr id="6" name="Image 0" descr="C:\temp\CoworkLab\v2\_working\screenshots\s1_01_input_en.png">    </p:cNvPr>
+          <p:cNvPr id="6" name="Image 0" descr="C:\temp\CoworkLab\v3\_working\screenshots\s1_01_input_en.png">    </p:cNvPr>
           <p:cNvPicPr>
             <a:picLocks noChangeAspect="1"/>
           </p:cNvPicPr>
@@ -3285,7 +3285,7 @@
       </p:sp>
       <p:pic>
         <p:nvPicPr>
-          <p:cNvPr id="9" name="Image 1" descr="C:\temp\CoworkLab\v2\_working\screenshots\s1_02_brief_done_en.png">    </p:cNvPr>
+          <p:cNvPr id="9" name="Image 1" descr="C:\temp\CoworkLab\v3\_working\screenshots\s1_04_schedule_done_en.png">    </p:cNvPr>
           <p:cNvPicPr>
             <a:picLocks noChangeAspect="1"/>
           </p:cNvPicPr>
@@ -4222,7 +4222,7 @@
         <p:spPr>
           <a:xfrm>
             <a:off x="4526280" y="566928"/>
-            <a:ext cx="7132320" cy="822960"/>
+            <a:ext cx="7132320" cy="1371600"/>
           </a:xfrm>
           <a:prstGeom prst="rect">
             <a:avLst/>
@@ -4263,7 +4263,7 @@
         </p:nvSpPr>
         <p:spPr>
           <a:xfrm>
-            <a:off x="4526280" y="1517904"/>
+            <a:off x="4526280" y="2066544"/>
             <a:ext cx="7132320" cy="365760"/>
           </a:xfrm>
           <a:prstGeom prst="rect">
@@ -4302,7 +4302,7 @@
         </p:nvSpPr>
         <p:spPr>
           <a:xfrm>
-            <a:off x="4526280" y="2020824"/>
+            <a:off x="4526280" y="2523744"/>
             <a:ext cx="457200" cy="457200"/>
           </a:xfrm>
           <a:prstGeom prst="ellipse">
@@ -4329,7 +4329,7 @@
         </p:nvSpPr>
         <p:spPr>
           <a:xfrm>
-            <a:off x="4526280" y="2020824"/>
+            <a:off x="4526280" y="2523744"/>
             <a:ext cx="457200" cy="457200"/>
           </a:xfrm>
           <a:prstGeom prst="rect">
@@ -4368,7 +4368,7 @@
         </p:nvSpPr>
         <p:spPr>
           <a:xfrm>
-            <a:off x="5166360" y="2002536"/>
+            <a:off x="5166360" y="2505456"/>
             <a:ext cx="6492240" cy="365760"/>
           </a:xfrm>
           <a:prstGeom prst="rect">
@@ -4407,7 +4407,7 @@
         </p:nvSpPr>
         <p:spPr>
           <a:xfrm>
-            <a:off x="5166360" y="2368296"/>
+            <a:off x="5166360" y="2871216"/>
             <a:ext cx="6492240" cy="502920"/>
           </a:xfrm>
           <a:prstGeom prst="rect">
@@ -4449,7 +4449,7 @@
         </p:nvSpPr>
         <p:spPr>
           <a:xfrm>
-            <a:off x="4526280" y="2990088"/>
+            <a:off x="4526280" y="3493008"/>
             <a:ext cx="457200" cy="457200"/>
           </a:xfrm>
           <a:prstGeom prst="ellipse">
@@ -4476,7 +4476,7 @@
         </p:nvSpPr>
         <p:spPr>
           <a:xfrm>
-            <a:off x="4526280" y="2990088"/>
+            <a:off x="4526280" y="3493008"/>
             <a:ext cx="457200" cy="457200"/>
           </a:xfrm>
           <a:prstGeom prst="rect">
@@ -4515,7 +4515,7 @@
         </p:nvSpPr>
         <p:spPr>
           <a:xfrm>
-            <a:off x="5166360" y="2971800"/>
+            <a:off x="5166360" y="3474720"/>
             <a:ext cx="6492240" cy="365760"/>
           </a:xfrm>
           <a:prstGeom prst="rect">
@@ -4554,7 +4554,7 @@
         </p:nvSpPr>
         <p:spPr>
           <a:xfrm>
-            <a:off x="5166360" y="3337560"/>
+            <a:off x="5166360" y="3840480"/>
             <a:ext cx="6492240" cy="502920"/>
           </a:xfrm>
           <a:prstGeom prst="rect">
@@ -4596,7 +4596,7 @@
         </p:nvSpPr>
         <p:spPr>
           <a:xfrm>
-            <a:off x="4526280" y="3959352"/>
+            <a:off x="4526280" y="4462272"/>
             <a:ext cx="457200" cy="457200"/>
           </a:xfrm>
           <a:prstGeom prst="ellipse">
@@ -4623,7 +4623,7 @@
         </p:nvSpPr>
         <p:spPr>
           <a:xfrm>
-            <a:off x="4526280" y="3959352"/>
+            <a:off x="4526280" y="4462272"/>
             <a:ext cx="457200" cy="457200"/>
           </a:xfrm>
           <a:prstGeom prst="rect">
@@ -4662,7 +4662,7 @@
         </p:nvSpPr>
         <p:spPr>
           <a:xfrm>
-            <a:off x="5166360" y="3941064"/>
+            <a:off x="5166360" y="4443984"/>
             <a:ext cx="6492240" cy="365760"/>
           </a:xfrm>
           <a:prstGeom prst="rect">
@@ -4701,7 +4701,7 @@
         </p:nvSpPr>
         <p:spPr>
           <a:xfrm>
-            <a:off x="5166360" y="4306824"/>
+            <a:off x="5166360" y="4809744"/>
             <a:ext cx="6492240" cy="502920"/>
           </a:xfrm>
           <a:prstGeom prst="rect">
@@ -4743,7 +4743,7 @@
         </p:nvSpPr>
         <p:spPr>
           <a:xfrm>
-            <a:off x="4526280" y="4928616"/>
+            <a:off x="4526280" y="5431536"/>
             <a:ext cx="457200" cy="457200"/>
           </a:xfrm>
           <a:prstGeom prst="ellipse">
@@ -4770,7 +4770,7 @@
         </p:nvSpPr>
         <p:spPr>
           <a:xfrm>
-            <a:off x="4526280" y="4928616"/>
+            <a:off x="4526280" y="5431536"/>
             <a:ext cx="457200" cy="457200"/>
           </a:xfrm>
           <a:prstGeom prst="rect">
@@ -4809,7 +4809,7 @@
         </p:nvSpPr>
         <p:spPr>
           <a:xfrm>
-            <a:off x="5166360" y="4910328"/>
+            <a:off x="5166360" y="5413248"/>
             <a:ext cx="6492240" cy="365760"/>
           </a:xfrm>
           <a:prstGeom prst="rect">
@@ -4848,7 +4848,7 @@
         </p:nvSpPr>
         <p:spPr>
           <a:xfrm>
-            <a:off x="5166360" y="5276088"/>
+            <a:off x="5166360" y="5779008"/>
             <a:ext cx="6492240" cy="502920"/>
           </a:xfrm>
           <a:prstGeom prst="rect">
@@ -5124,7 +5124,7 @@
       </p:sp>
       <p:pic>
         <p:nvPicPr>
-          <p:cNvPr id="6" name="Image 0" descr="C:\temp\CoworkLab\v2\_working\screenshots\s2_01_input_en.png">    </p:cNvPr>
+          <p:cNvPr id="6" name="Image 0" descr="C:\temp\CoworkLab\v3\_working\screenshots\s2_01_input_en.png">    </p:cNvPr>
           <p:cNvPicPr>
             <a:picLocks noChangeAspect="1"/>
           </p:cNvPicPr>
@@ -5219,7 +5219,7 @@
       </p:sp>
       <p:pic>
         <p:nvPicPr>
-          <p:cNvPr id="9" name="Image 1" descr="C:\temp\CoworkLab\v2\_working\screenshots\s2_02_brief_done_en.png">    </p:cNvPr>
+          <p:cNvPr id="9" name="Image 1" descr="C:\temp\CoworkLab\v3\_working\screenshots\s2_07_meeting_done_en.png">    </p:cNvPr>
           <p:cNvPicPr>
             <a:picLocks noChangeAspect="1"/>
           </p:cNvPicPr>
@@ -6095,7 +6095,7 @@
         <p:spPr>
           <a:xfrm>
             <a:off x="4526280" y="566928"/>
-            <a:ext cx="7132320" cy="1097280"/>
+            <a:ext cx="7132320" cy="1645920"/>
           </a:xfrm>
           <a:prstGeom prst="rect">
             <a:avLst/>
@@ -6136,7 +6136,7 @@
         </p:nvSpPr>
         <p:spPr>
           <a:xfrm>
-            <a:off x="4526280" y="1792224"/>
+            <a:off x="4526280" y="2340864"/>
             <a:ext cx="7132320" cy="365760"/>
           </a:xfrm>
           <a:prstGeom prst="rect">
@@ -6175,7 +6175,7 @@
         </p:nvSpPr>
         <p:spPr>
           <a:xfrm>
-            <a:off x="4526280" y="2295144"/>
+            <a:off x="4526280" y="2798064"/>
             <a:ext cx="457200" cy="457200"/>
           </a:xfrm>
           <a:prstGeom prst="ellipse">
@@ -6202,7 +6202,7 @@
         </p:nvSpPr>
         <p:spPr>
           <a:xfrm>
-            <a:off x="4526280" y="2295144"/>
+            <a:off x="4526280" y="2798064"/>
             <a:ext cx="457200" cy="457200"/>
           </a:xfrm>
           <a:prstGeom prst="rect">
@@ -6241,7 +6241,7 @@
         </p:nvSpPr>
         <p:spPr>
           <a:xfrm>
-            <a:off x="5166360" y="2276856"/>
+            <a:off x="5166360" y="2779776"/>
             <a:ext cx="6492240" cy="365760"/>
           </a:xfrm>
           <a:prstGeom prst="rect">
@@ -6280,7 +6280,7 @@
         </p:nvSpPr>
         <p:spPr>
           <a:xfrm>
-            <a:off x="5166360" y="2642616"/>
+            <a:off x="5166360" y="3145536"/>
             <a:ext cx="6492240" cy="502920"/>
           </a:xfrm>
           <a:prstGeom prst="rect">
@@ -6322,7 +6322,7 @@
         </p:nvSpPr>
         <p:spPr>
           <a:xfrm>
-            <a:off x="4526280" y="3264408"/>
+            <a:off x="4526280" y="3715512"/>
             <a:ext cx="457200" cy="457200"/>
           </a:xfrm>
           <a:prstGeom prst="ellipse">
@@ -6349,7 +6349,7 @@
         </p:nvSpPr>
         <p:spPr>
           <a:xfrm>
-            <a:off x="4526280" y="3264408"/>
+            <a:off x="4526280" y="3715512"/>
             <a:ext cx="457200" cy="457200"/>
           </a:xfrm>
           <a:prstGeom prst="rect">
@@ -6388,7 +6388,7 @@
         </p:nvSpPr>
         <p:spPr>
           <a:xfrm>
-            <a:off x="5166360" y="3246120"/>
+            <a:off x="5166360" y="3697224"/>
             <a:ext cx="6492240" cy="365760"/>
           </a:xfrm>
           <a:prstGeom prst="rect">
@@ -6427,7 +6427,7 @@
         </p:nvSpPr>
         <p:spPr>
           <a:xfrm>
-            <a:off x="5166360" y="3611880"/>
+            <a:off x="5166360" y="4062984"/>
             <a:ext cx="6492240" cy="502920"/>
           </a:xfrm>
           <a:prstGeom prst="rect">
@@ -6469,7 +6469,7 @@
         </p:nvSpPr>
         <p:spPr>
           <a:xfrm>
-            <a:off x="4526280" y="4233672"/>
+            <a:off x="4526280" y="4632960"/>
             <a:ext cx="457200" cy="457200"/>
           </a:xfrm>
           <a:prstGeom prst="ellipse">
@@ -6496,7 +6496,7 @@
         </p:nvSpPr>
         <p:spPr>
           <a:xfrm>
-            <a:off x="4526280" y="4233672"/>
+            <a:off x="4526280" y="4632960"/>
             <a:ext cx="457200" cy="457200"/>
           </a:xfrm>
           <a:prstGeom prst="rect">
@@ -6535,7 +6535,7 @@
         </p:nvSpPr>
         <p:spPr>
           <a:xfrm>
-            <a:off x="5166360" y="4215384"/>
+            <a:off x="5166360" y="4614672"/>
             <a:ext cx="6492240" cy="365760"/>
           </a:xfrm>
           <a:prstGeom prst="rect">
@@ -6574,7 +6574,7 @@
         </p:nvSpPr>
         <p:spPr>
           <a:xfrm>
-            <a:off x="5166360" y="4581144"/>
+            <a:off x="5166360" y="4980432"/>
             <a:ext cx="6492240" cy="502920"/>
           </a:xfrm>
           <a:prstGeom prst="rect">
@@ -6616,7 +6616,7 @@
         </p:nvSpPr>
         <p:spPr>
           <a:xfrm>
-            <a:off x="4526280" y="5202936"/>
+            <a:off x="4526280" y="5550408"/>
             <a:ext cx="457200" cy="457200"/>
           </a:xfrm>
           <a:prstGeom prst="ellipse">
@@ -6643,7 +6643,7 @@
         </p:nvSpPr>
         <p:spPr>
           <a:xfrm>
-            <a:off x="4526280" y="5202936"/>
+            <a:off x="4526280" y="5550408"/>
             <a:ext cx="457200" cy="457200"/>
           </a:xfrm>
           <a:prstGeom prst="rect">
@@ -6682,7 +6682,7 @@
         </p:nvSpPr>
         <p:spPr>
           <a:xfrm>
-            <a:off x="5166360" y="5184648"/>
+            <a:off x="5166360" y="5532120"/>
             <a:ext cx="6492240" cy="365760"/>
           </a:xfrm>
           <a:prstGeom prst="rect">
@@ -6721,7 +6721,7 @@
         </p:nvSpPr>
         <p:spPr>
           <a:xfrm>
-            <a:off x="5166360" y="5550408"/>
+            <a:off x="5166360" y="5897880"/>
             <a:ext cx="6492240" cy="502920"/>
           </a:xfrm>
           <a:prstGeom prst="rect">
@@ -6997,7 +6997,7 @@
       </p:sp>
       <p:pic>
         <p:nvPicPr>
-          <p:cNvPr id="6" name="Image 0" descr="C:\temp\CoworkLab\v2\_working\screenshots\s3_01_input_en.png">    </p:cNvPr>
+          <p:cNvPr id="6" name="Image 0" descr="C:\temp\CoworkLab\v3\_working\screenshots\s3_01_input_en.png">    </p:cNvPr>
           <p:cNvPicPr>
             <a:picLocks noChangeAspect="1"/>
           </p:cNvPicPr>
@@ -7092,7 +7092,7 @@
       </p:sp>
       <p:pic>
         <p:nvPicPr>
-          <p:cNvPr id="9" name="Image 1" descr="C:\temp\CoworkLab\v2\_working\screenshots\s3_02_dashboard_done_en.png">    </p:cNvPr>
+          <p:cNvPr id="9" name="Image 1" descr="C:\temp\CoworkLab\v3\_working\screenshots\s3_05_cards_en.png">    </p:cNvPr>
           <p:cNvPicPr>
             <a:picLocks noChangeAspect="1"/>
           </p:cNvPicPr>
@@ -7968,7 +7968,7 @@
         <p:spPr>
           <a:xfrm>
             <a:off x="4526280" y="566928"/>
-            <a:ext cx="7132320" cy="1097280"/>
+            <a:ext cx="7132320" cy="1645920"/>
           </a:xfrm>
           <a:prstGeom prst="rect">
             <a:avLst/>
@@ -8009,7 +8009,7 @@
         </p:nvSpPr>
         <p:spPr>
           <a:xfrm>
-            <a:off x="4526280" y="1792224"/>
+            <a:off x="4526280" y="2340864"/>
             <a:ext cx="7132320" cy="365760"/>
           </a:xfrm>
           <a:prstGeom prst="rect">
@@ -8048,7 +8048,7 @@
         </p:nvSpPr>
         <p:spPr>
           <a:xfrm>
-            <a:off x="4526280" y="2295144"/>
+            <a:off x="4526280" y="2798064"/>
             <a:ext cx="457200" cy="457200"/>
           </a:xfrm>
           <a:prstGeom prst="ellipse">
@@ -8075,7 +8075,7 @@
         </p:nvSpPr>
         <p:spPr>
           <a:xfrm>
-            <a:off x="4526280" y="2295144"/>
+            <a:off x="4526280" y="2798064"/>
             <a:ext cx="457200" cy="457200"/>
           </a:xfrm>
           <a:prstGeom prst="rect">
@@ -8114,7 +8114,7 @@
         </p:nvSpPr>
         <p:spPr>
           <a:xfrm>
-            <a:off x="5166360" y="2276856"/>
+            <a:off x="5166360" y="2779776"/>
             <a:ext cx="6492240" cy="365760"/>
           </a:xfrm>
           <a:prstGeom prst="rect">
@@ -8153,7 +8153,7 @@
         </p:nvSpPr>
         <p:spPr>
           <a:xfrm>
-            <a:off x="5166360" y="2642616"/>
+            <a:off x="5166360" y="3145536"/>
             <a:ext cx="6492240" cy="502920"/>
           </a:xfrm>
           <a:prstGeom prst="rect">
@@ -8195,7 +8195,7 @@
         </p:nvSpPr>
         <p:spPr>
           <a:xfrm>
-            <a:off x="4526280" y="3264408"/>
+            <a:off x="4526280" y="3715512"/>
             <a:ext cx="457200" cy="457200"/>
           </a:xfrm>
           <a:prstGeom prst="ellipse">
@@ -8222,7 +8222,7 @@
         </p:nvSpPr>
         <p:spPr>
           <a:xfrm>
-            <a:off x="4526280" y="3264408"/>
+            <a:off x="4526280" y="3715512"/>
             <a:ext cx="457200" cy="457200"/>
           </a:xfrm>
           <a:prstGeom prst="rect">
@@ -8261,7 +8261,7 @@
         </p:nvSpPr>
         <p:spPr>
           <a:xfrm>
-            <a:off x="5166360" y="3246120"/>
+            <a:off x="5166360" y="3697224"/>
             <a:ext cx="6492240" cy="365760"/>
           </a:xfrm>
           <a:prstGeom prst="rect">
@@ -8300,7 +8300,7 @@
         </p:nvSpPr>
         <p:spPr>
           <a:xfrm>
-            <a:off x="5166360" y="3611880"/>
+            <a:off x="5166360" y="4062984"/>
             <a:ext cx="6492240" cy="502920"/>
           </a:xfrm>
           <a:prstGeom prst="rect">
@@ -8342,7 +8342,7 @@
         </p:nvSpPr>
         <p:spPr>
           <a:xfrm>
-            <a:off x="4526280" y="4233672"/>
+            <a:off x="4526280" y="4632960"/>
             <a:ext cx="457200" cy="457200"/>
           </a:xfrm>
           <a:prstGeom prst="ellipse">
@@ -8369,7 +8369,7 @@
         </p:nvSpPr>
         <p:spPr>
           <a:xfrm>
-            <a:off x="4526280" y="4233672"/>
+            <a:off x="4526280" y="4632960"/>
             <a:ext cx="457200" cy="457200"/>
           </a:xfrm>
           <a:prstGeom prst="rect">
@@ -8408,7 +8408,7 @@
         </p:nvSpPr>
         <p:spPr>
           <a:xfrm>
-            <a:off x="5166360" y="4215384"/>
+            <a:off x="5166360" y="4614672"/>
             <a:ext cx="6492240" cy="365760"/>
           </a:xfrm>
           <a:prstGeom prst="rect">
@@ -8447,7 +8447,7 @@
         </p:nvSpPr>
         <p:spPr>
           <a:xfrm>
-            <a:off x="5166360" y="4581144"/>
+            <a:off x="5166360" y="4980432"/>
             <a:ext cx="6492240" cy="502920"/>
           </a:xfrm>
           <a:prstGeom prst="rect">
@@ -8489,7 +8489,7 @@
         </p:nvSpPr>
         <p:spPr>
           <a:xfrm>
-            <a:off x="4526280" y="5202936"/>
+            <a:off x="4526280" y="5550408"/>
             <a:ext cx="457200" cy="457200"/>
           </a:xfrm>
           <a:prstGeom prst="ellipse">
@@ -8516,7 +8516,7 @@
         </p:nvSpPr>
         <p:spPr>
           <a:xfrm>
-            <a:off x="4526280" y="5202936"/>
+            <a:off x="4526280" y="5550408"/>
             <a:ext cx="457200" cy="457200"/>
           </a:xfrm>
           <a:prstGeom prst="rect">
@@ -8555,7 +8555,7 @@
         </p:nvSpPr>
         <p:spPr>
           <a:xfrm>
-            <a:off x="5166360" y="5184648"/>
+            <a:off x="5166360" y="5532120"/>
             <a:ext cx="6492240" cy="365760"/>
           </a:xfrm>
           <a:prstGeom prst="rect">
@@ -8594,7 +8594,7 @@
         </p:nvSpPr>
         <p:spPr>
           <a:xfrm>
-            <a:off x="5166360" y="5550408"/>
+            <a:off x="5166360" y="5897880"/>
             <a:ext cx="6492240" cy="502920"/>
           </a:xfrm>
           <a:prstGeom prst="rect">
@@ -8870,7 +8870,7 @@
       </p:sp>
       <p:pic>
         <p:nvPicPr>
-          <p:cNvPr id="6" name="Image 0" descr="C:\temp\CoworkLab\v2\_working\screenshots\s4_01_input_en.png">    </p:cNvPr>
+          <p:cNvPr id="6" name="Image 0" descr="C:\temp\CoworkLab\v3\_working\screenshots\s4_01_input_en.png">    </p:cNvPr>
           <p:cNvPicPr>
             <a:picLocks noChangeAspect="1"/>
           </p:cNvPicPr>
@@ -8965,7 +8965,7 @@
       </p:sp>
       <p:pic>
         <p:nvPicPr>
-          <p:cNvPr id="9" name="Image 1" descr="C:\temp\CoworkLab\v2\_working\screenshots\s4_03_deck_done_en.png">    </p:cNvPr>
+          <p:cNvPr id="9" name="Image 1" descr="C:\temp\CoworkLab\v3\_working\screenshots\s4_05_deck_done_en.png">    </p:cNvPr>
           <p:cNvPicPr>
             <a:picLocks noChangeAspect="1"/>
           </p:cNvPicPr>
@@ -9841,7 +9841,7 @@
         <p:spPr>
           <a:xfrm>
             <a:off x="4526280" y="566928"/>
-            <a:ext cx="7132320" cy="822960"/>
+            <a:ext cx="7132320" cy="1097280"/>
           </a:xfrm>
           <a:prstGeom prst="rect">
             <a:avLst/>
@@ -9882,7 +9882,7 @@
         </p:nvSpPr>
         <p:spPr>
           <a:xfrm>
-            <a:off x="4526280" y="1517904"/>
+            <a:off x="4526280" y="1792224"/>
             <a:ext cx="7132320" cy="365760"/>
           </a:xfrm>
           <a:prstGeom prst="rect">
@@ -9921,7 +9921,7 @@
         </p:nvSpPr>
         <p:spPr>
           <a:xfrm>
-            <a:off x="4526280" y="2020824"/>
+            <a:off x="4526280" y="2249424"/>
             <a:ext cx="457200" cy="457200"/>
           </a:xfrm>
           <a:prstGeom prst="ellipse">
@@ -9948,7 +9948,7 @@
         </p:nvSpPr>
         <p:spPr>
           <a:xfrm>
-            <a:off x="4526280" y="2020824"/>
+            <a:off x="4526280" y="2249424"/>
             <a:ext cx="457200" cy="457200"/>
           </a:xfrm>
           <a:prstGeom prst="rect">
@@ -9987,7 +9987,7 @@
         </p:nvSpPr>
         <p:spPr>
           <a:xfrm>
-            <a:off x="5166360" y="2002536"/>
+            <a:off x="5166360" y="2231136"/>
             <a:ext cx="6492240" cy="365760"/>
           </a:xfrm>
           <a:prstGeom prst="rect">
@@ -10026,7 +10026,7 @@
         </p:nvSpPr>
         <p:spPr>
           <a:xfrm>
-            <a:off x="5166360" y="2368296"/>
+            <a:off x="5166360" y="2596896"/>
             <a:ext cx="6492240" cy="502920"/>
           </a:xfrm>
           <a:prstGeom prst="rect">
@@ -10068,7 +10068,7 @@
         </p:nvSpPr>
         <p:spPr>
           <a:xfrm>
-            <a:off x="4526280" y="2990088"/>
+            <a:off x="4526280" y="3218688"/>
             <a:ext cx="457200" cy="457200"/>
           </a:xfrm>
           <a:prstGeom prst="ellipse">
@@ -10095,7 +10095,7 @@
         </p:nvSpPr>
         <p:spPr>
           <a:xfrm>
-            <a:off x="4526280" y="2990088"/>
+            <a:off x="4526280" y="3218688"/>
             <a:ext cx="457200" cy="457200"/>
           </a:xfrm>
           <a:prstGeom prst="rect">
@@ -10134,7 +10134,7 @@
         </p:nvSpPr>
         <p:spPr>
           <a:xfrm>
-            <a:off x="5166360" y="2971800"/>
+            <a:off x="5166360" y="3200400"/>
             <a:ext cx="6492240" cy="365760"/>
           </a:xfrm>
           <a:prstGeom prst="rect">
@@ -10173,7 +10173,7 @@
         </p:nvSpPr>
         <p:spPr>
           <a:xfrm>
-            <a:off x="5166360" y="3337560"/>
+            <a:off x="5166360" y="3566160"/>
             <a:ext cx="6492240" cy="502920"/>
           </a:xfrm>
           <a:prstGeom prst="rect">
@@ -10215,7 +10215,7 @@
         </p:nvSpPr>
         <p:spPr>
           <a:xfrm>
-            <a:off x="4526280" y="3959352"/>
+            <a:off x="4526280" y="4187952"/>
             <a:ext cx="457200" cy="457200"/>
           </a:xfrm>
           <a:prstGeom prst="ellipse">
@@ -10242,7 +10242,7 @@
         </p:nvSpPr>
         <p:spPr>
           <a:xfrm>
-            <a:off x="4526280" y="3959352"/>
+            <a:off x="4526280" y="4187952"/>
             <a:ext cx="457200" cy="457200"/>
           </a:xfrm>
           <a:prstGeom prst="rect">
@@ -10281,7 +10281,7 @@
         </p:nvSpPr>
         <p:spPr>
           <a:xfrm>
-            <a:off x="5166360" y="3941064"/>
+            <a:off x="5166360" y="4169664"/>
             <a:ext cx="6492240" cy="365760"/>
           </a:xfrm>
           <a:prstGeom prst="rect">
@@ -10320,7 +10320,7 @@
         </p:nvSpPr>
         <p:spPr>
           <a:xfrm>
-            <a:off x="5166360" y="4306824"/>
+            <a:off x="5166360" y="4535424"/>
             <a:ext cx="6492240" cy="502920"/>
           </a:xfrm>
           <a:prstGeom prst="rect">
@@ -10362,7 +10362,7 @@
         </p:nvSpPr>
         <p:spPr>
           <a:xfrm>
-            <a:off x="4526280" y="4928616"/>
+            <a:off x="4526280" y="5157216"/>
             <a:ext cx="457200" cy="457200"/>
           </a:xfrm>
           <a:prstGeom prst="ellipse">
@@ -10389,7 +10389,7 @@
         </p:nvSpPr>
         <p:spPr>
           <a:xfrm>
-            <a:off x="4526280" y="4928616"/>
+            <a:off x="4526280" y="5157216"/>
             <a:ext cx="457200" cy="457200"/>
           </a:xfrm>
           <a:prstGeom prst="rect">
@@ -10428,7 +10428,7 @@
         </p:nvSpPr>
         <p:spPr>
           <a:xfrm>
-            <a:off x="5166360" y="4910328"/>
+            <a:off x="5166360" y="5138928"/>
             <a:ext cx="6492240" cy="365760"/>
           </a:xfrm>
           <a:prstGeom prst="rect">
@@ -10467,7 +10467,7 @@
         </p:nvSpPr>
         <p:spPr>
           <a:xfrm>
-            <a:off x="5166360" y="5276088"/>
+            <a:off x="5166360" y="5504688"/>
             <a:ext cx="6492240" cy="502920"/>
           </a:xfrm>
           <a:prstGeom prst="rect">
@@ -10743,7 +10743,7 @@
       </p:sp>
       <p:pic>
         <p:nvPicPr>
-          <p:cNvPr id="6" name="Image 0" descr="C:\temp\CoworkLab\v2\_working\screenshots\s5_01_howto_en.png">    </p:cNvPr>
+          <p:cNvPr id="6" name="Image 0" descr="C:\temp\CoworkLab\v3\_working\screenshots\s5_01_howto_input_en.png">    </p:cNvPr>
           <p:cNvPicPr>
             <a:picLocks noChangeAspect="1"/>
           </p:cNvPicPr>
@@ -10838,7 +10838,7 @@
       </p:sp>
       <p:pic>
         <p:nvPicPr>
-          <p:cNvPr id="9" name="Image 1" descr="C:\temp\CoworkLab\v2\_working\screenshots\s5_03_report_done_en.png">    </p:cNvPr>
+          <p:cNvPr id="9" name="Image 1" descr="C:\temp\CoworkLab\v3\_working\screenshots\s5_10_trigger_done_en.png">    </p:cNvPr>
           <p:cNvPicPr>
             <a:picLocks noChangeAspect="1"/>
           </p:cNvPicPr>
@@ -21257,24 +21257,24 @@
         </p:nvSpPr>
         <p:spPr>
           <a:xfrm>
-            <a:off x="731520" y="3218688"/>
-            <a:ext cx="1706819" cy="274320"/>
-          </a:xfrm>
-          <a:prstGeom prst="rect">
-            <a:avLst/>
-          </a:prstGeom>
-          <a:noFill/>
-          <a:ln/>
-        </p:spPr>
-        <p:txBody>
-          <a:bodyPr wrap="square" rtlCol="0" anchor="ctr"/>
+            <a:off x="731520" y="3163824"/>
+            <a:ext cx="1706819" cy="349352"/>
+          </a:xfrm>
+          <a:prstGeom prst="rect">
+            <a:avLst/>
+          </a:prstGeom>
+          <a:noFill/>
+          <a:ln/>
+        </p:spPr>
+        <p:txBody>
+          <a:bodyPr wrap="square" rtlCol="0" anchor="t"/>
           <a:lstStyle/>
           <a:p>
             <a:pPr algn="ctr" indent="0" marL="0">
               <a:buNone/>
             </a:pPr>
             <a:r>
-              <a:rPr lang="en-US" sz="1150" b="1" dirty="0">
+              <a:rPr lang="en-US" sz="1058" b="1" dirty="0">
                 <a:solidFill>
                   <a:srgbClr val="CA5010"/>
                 </a:solidFill>
@@ -21284,7 +21284,7 @@
               </a:rPr>
               <a:t>Productivity / Personal</a:t>
             </a:r>
-            <a:endParaRPr lang="en-US" sz="1150" dirty="0"/>
+            <a:endParaRPr lang="en-US" sz="1058" dirty="0"/>
           </a:p>
         </p:txBody>
       </p:sp>
@@ -21296,24 +21296,24 @@
         </p:nvSpPr>
         <p:spPr>
           <a:xfrm>
-            <a:off x="731520" y="3493008"/>
-            <a:ext cx="1706819" cy="548640"/>
-          </a:xfrm>
-          <a:prstGeom prst="rect">
-            <a:avLst/>
-          </a:prstGeom>
-          <a:noFill/>
-          <a:ln/>
-        </p:spPr>
-        <p:txBody>
-          <a:bodyPr wrap="square" rtlCol="0" anchor="ctr"/>
+            <a:off x="731520" y="3568040"/>
+            <a:ext cx="1706819" cy="455676"/>
+          </a:xfrm>
+          <a:prstGeom prst="rect">
+            <a:avLst/>
+          </a:prstGeom>
+          <a:noFill/>
+          <a:ln/>
+        </p:spPr>
+        <p:txBody>
+          <a:bodyPr wrap="square" rtlCol="0" anchor="t"/>
           <a:lstStyle/>
           <a:p>
             <a:pPr algn="ctr" indent="0" marL="0">
               <a:buNone/>
             </a:pPr>
             <a:r>
-              <a:rPr lang="en-US" sz="1500" b="1" dirty="0">
+              <a:rPr lang="en-US" sz="1380" b="1" dirty="0">
                 <a:solidFill>
                   <a:srgbClr val="1E2235"/>
                 </a:solidFill>
@@ -21323,7 +21323,7 @@
               </a:rPr>
               <a:t>Inbox Triage on Schedule</a:t>
             </a:r>
-            <a:endParaRPr lang="en-US" sz="1500" dirty="0"/>
+            <a:endParaRPr lang="en-US" sz="1380" dirty="0"/>
           </a:p>
         </p:txBody>
       </p:sp>
@@ -21335,27 +21335,27 @@
         </p:nvSpPr>
         <p:spPr>
           <a:xfrm>
-            <a:off x="731520" y="4114800"/>
-            <a:ext cx="1706819" cy="457200"/>
-          </a:xfrm>
-          <a:prstGeom prst="rect">
-            <a:avLst/>
-          </a:prstGeom>
-          <a:noFill/>
-          <a:ln/>
-        </p:spPr>
-        <p:txBody>
-          <a:bodyPr wrap="square" rtlCol="0" anchor="ctr"/>
+            <a:off x="731520" y="4106012"/>
+            <a:ext cx="1706819" cy="546811"/>
+          </a:xfrm>
+          <a:prstGeom prst="rect">
+            <a:avLst/>
+          </a:prstGeom>
+          <a:noFill/>
+          <a:ln/>
+        </p:spPr>
+        <p:txBody>
+          <a:bodyPr wrap="square" rtlCol="0" anchor="t"/>
           <a:lstStyle/>
           <a:p>
             <a:pPr algn="ctr" indent="0" marL="0">
               <a:lnSpc>
-                <a:spcPct val="110000"/>
+                <a:spcPct val="105000"/>
               </a:lnSpc>
               <a:buNone/>
             </a:pPr>
             <a:r>
-              <a:rPr lang="en-US" sz="1200" dirty="0">
+              <a:rPr lang="en-US" sz="1104" dirty="0">
                 <a:solidFill>
                   <a:srgbClr val="5B6079"/>
                 </a:solidFill>
@@ -21365,7 +21365,7 @@
               </a:rPr>
               <a:t>Email · Daily Briefing · Scheduled prompt</a:t>
             </a:r>
-            <a:endParaRPr lang="en-US" sz="1200" dirty="0"/>
+            <a:endParaRPr lang="en-US" sz="1104" dirty="0"/>
           </a:p>
         </p:txBody>
       </p:sp>
@@ -21377,24 +21377,24 @@
         </p:nvSpPr>
         <p:spPr>
           <a:xfrm>
-            <a:off x="731520" y="4645152"/>
-            <a:ext cx="1706819" cy="457200"/>
-          </a:xfrm>
-          <a:prstGeom prst="rect">
-            <a:avLst/>
-          </a:prstGeom>
-          <a:noFill/>
-          <a:ln/>
-        </p:spPr>
-        <p:txBody>
-          <a:bodyPr wrap="square" rtlCol="0" anchor="ctr"/>
+            <a:off x="731520" y="4735119"/>
+            <a:ext cx="1706819" cy="334162"/>
+          </a:xfrm>
+          <a:prstGeom prst="rect">
+            <a:avLst/>
+          </a:prstGeom>
+          <a:noFill/>
+          <a:ln/>
+        </p:spPr>
+        <p:txBody>
+          <a:bodyPr wrap="square" rtlCol="0" anchor="t"/>
           <a:lstStyle/>
           <a:p>
             <a:pPr algn="ctr" indent="0" marL="0">
               <a:buNone/>
             </a:pPr>
             <a:r>
-              <a:rPr lang="en-US" sz="1100" dirty="0">
+              <a:rPr lang="en-US" sz="1012" dirty="0">
                 <a:solidFill>
                   <a:srgbClr val="9AA0C0"/>
                 </a:solidFill>
@@ -21404,14 +21404,14 @@
               </a:rPr>
               <a:t>~10 min</a:t>
             </a:r>
-            <a:endParaRPr lang="en-US" sz="1100" dirty="0"/>
+            <a:endParaRPr lang="en-US" sz="1012" dirty="0"/>
           </a:p>
           <a:p>
             <a:pPr algn="ctr" indent="0" marL="0">
               <a:buNone/>
             </a:pPr>
             <a:r>
-              <a:rPr lang="en-US" sz="1100" dirty="0">
+              <a:rPr lang="en-US" sz="1012" dirty="0">
                 <a:solidFill>
                   <a:srgbClr val="9AA0C0"/>
                 </a:solidFill>
@@ -21421,7 +21421,7 @@
               </a:rPr>
               <a:t> ★☆☆</a:t>
             </a:r>
-            <a:endParaRPr lang="en-US" sz="1100" dirty="0"/>
+            <a:endParaRPr lang="en-US" sz="1012" dirty="0"/>
           </a:p>
         </p:txBody>
       </p:sp>
@@ -21529,24 +21529,24 @@
         </p:nvSpPr>
         <p:spPr>
           <a:xfrm>
-            <a:off x="2986979" y="3218688"/>
-            <a:ext cx="1706819" cy="274320"/>
-          </a:xfrm>
-          <a:prstGeom prst="rect">
-            <a:avLst/>
-          </a:prstGeom>
-          <a:noFill/>
-          <a:ln/>
-        </p:spPr>
-        <p:txBody>
-          <a:bodyPr wrap="square" rtlCol="0" anchor="ctr"/>
+            <a:off x="2986979" y="3163824"/>
+            <a:ext cx="1706819" cy="174676"/>
+          </a:xfrm>
+          <a:prstGeom prst="rect">
+            <a:avLst/>
+          </a:prstGeom>
+          <a:noFill/>
+          <a:ln/>
+        </p:spPr>
+        <p:txBody>
+          <a:bodyPr wrap="square" rtlCol="0" anchor="t"/>
           <a:lstStyle/>
           <a:p>
             <a:pPr algn="ctr" indent="0" marL="0">
               <a:buNone/>
             </a:pPr>
             <a:r>
-              <a:rPr lang="en-US" sz="1150" b="1" dirty="0">
+              <a:rPr lang="en-US" sz="1058" b="1" dirty="0">
                 <a:solidFill>
                   <a:srgbClr val="0067B8"/>
                 </a:solidFill>
@@ -21556,7 +21556,7 @@
               </a:rPr>
               <a:t>Sales / Pre-sales</a:t>
             </a:r>
-            <a:endParaRPr lang="en-US" sz="1150" dirty="0"/>
+            <a:endParaRPr lang="en-US" sz="1058" dirty="0"/>
           </a:p>
         </p:txBody>
       </p:sp>
@@ -21568,24 +21568,24 @@
         </p:nvSpPr>
         <p:spPr>
           <a:xfrm>
-            <a:off x="2986979" y="3493008"/>
-            <a:ext cx="1706819" cy="548640"/>
-          </a:xfrm>
-          <a:prstGeom prst="rect">
-            <a:avLst/>
-          </a:prstGeom>
-          <a:noFill/>
-          <a:ln/>
-        </p:spPr>
-        <p:txBody>
-          <a:bodyPr wrap="square" rtlCol="0" anchor="ctr"/>
+            <a:off x="2986979" y="3393364"/>
+            <a:ext cx="1706819" cy="455676"/>
+          </a:xfrm>
+          <a:prstGeom prst="rect">
+            <a:avLst/>
+          </a:prstGeom>
+          <a:noFill/>
+          <a:ln/>
+        </p:spPr>
+        <p:txBody>
+          <a:bodyPr wrap="square" rtlCol="0" anchor="t"/>
           <a:lstStyle/>
           <a:p>
             <a:pPr algn="ctr" indent="0" marL="0">
               <a:buNone/>
             </a:pPr>
             <a:r>
-              <a:rPr lang="en-US" sz="1500" b="1" dirty="0">
+              <a:rPr lang="en-US" sz="1380" b="1" dirty="0">
                 <a:solidFill>
                   <a:srgbClr val="1E2235"/>
                 </a:solidFill>
@@ -21595,7 +21595,7 @@
               </a:rPr>
               <a:t>Client Visit End-to-End</a:t>
             </a:r>
-            <a:endParaRPr lang="en-US" sz="1500" dirty="0"/>
+            <a:endParaRPr lang="en-US" sz="1380" dirty="0"/>
           </a:p>
         </p:txBody>
       </p:sp>
@@ -21607,27 +21607,27 @@
         </p:nvSpPr>
         <p:spPr>
           <a:xfrm>
-            <a:off x="2986979" y="4114800"/>
-            <a:ext cx="1706819" cy="457200"/>
-          </a:xfrm>
-          <a:prstGeom prst="rect">
-            <a:avLst/>
-          </a:prstGeom>
-          <a:noFill/>
-          <a:ln/>
-        </p:spPr>
-        <p:txBody>
-          <a:bodyPr wrap="square" rtlCol="0" anchor="ctr"/>
+            <a:off x="2986979" y="3931336"/>
+            <a:ext cx="1706819" cy="546811"/>
+          </a:xfrm>
+          <a:prstGeom prst="rect">
+            <a:avLst/>
+          </a:prstGeom>
+          <a:noFill/>
+          <a:ln/>
+        </p:spPr>
+        <p:txBody>
+          <a:bodyPr wrap="square" rtlCol="0" anchor="t"/>
           <a:lstStyle/>
           <a:p>
             <a:pPr algn="ctr" indent="0" marL="0">
               <a:lnSpc>
-                <a:spcPct val="110000"/>
+                <a:spcPct val="105000"/>
               </a:lnSpc>
               <a:buNone/>
             </a:pPr>
             <a:r>
-              <a:rPr lang="en-US" sz="1200" dirty="0">
+              <a:rPr lang="en-US" sz="1104" dirty="0">
                 <a:solidFill>
                   <a:srgbClr val="5B6079"/>
                 </a:solidFill>
@@ -21637,7 +21637,7 @@
               </a:rPr>
               <a:t>Word · Email · Scheduling · Calendar Management</a:t>
             </a:r>
-            <a:endParaRPr lang="en-US" sz="1200" dirty="0"/>
+            <a:endParaRPr lang="en-US" sz="1104" dirty="0"/>
           </a:p>
         </p:txBody>
       </p:sp>
@@ -21649,24 +21649,24 @@
         </p:nvSpPr>
         <p:spPr>
           <a:xfrm>
-            <a:off x="2986979" y="4645152"/>
-            <a:ext cx="1706819" cy="457200"/>
-          </a:xfrm>
-          <a:prstGeom prst="rect">
-            <a:avLst/>
-          </a:prstGeom>
-          <a:noFill/>
-          <a:ln/>
-        </p:spPr>
-        <p:txBody>
-          <a:bodyPr wrap="square" rtlCol="0" anchor="ctr"/>
+            <a:off x="2986979" y="4560443"/>
+            <a:ext cx="1706819" cy="334162"/>
+          </a:xfrm>
+          <a:prstGeom prst="rect">
+            <a:avLst/>
+          </a:prstGeom>
+          <a:noFill/>
+          <a:ln/>
+        </p:spPr>
+        <p:txBody>
+          <a:bodyPr wrap="square" rtlCol="0" anchor="t"/>
           <a:lstStyle/>
           <a:p>
             <a:pPr algn="ctr" indent="0" marL="0">
               <a:buNone/>
             </a:pPr>
             <a:r>
-              <a:rPr lang="en-US" sz="1100" dirty="0">
+              <a:rPr lang="en-US" sz="1012" dirty="0">
                 <a:solidFill>
                   <a:srgbClr val="9AA0C0"/>
                 </a:solidFill>
@@ -21676,14 +21676,14 @@
               </a:rPr>
               <a:t>~12 min</a:t>
             </a:r>
-            <a:endParaRPr lang="en-US" sz="1100" dirty="0"/>
+            <a:endParaRPr lang="en-US" sz="1012" dirty="0"/>
           </a:p>
           <a:p>
             <a:pPr algn="ctr" indent="0" marL="0">
               <a:buNone/>
             </a:pPr>
             <a:r>
-              <a:rPr lang="en-US" sz="1100" dirty="0">
+              <a:rPr lang="en-US" sz="1012" dirty="0">
                 <a:solidFill>
                   <a:srgbClr val="9AA0C0"/>
                 </a:solidFill>
@@ -21693,7 +21693,7 @@
               </a:rPr>
               <a:t> ★☆☆</a:t>
             </a:r>
-            <a:endParaRPr lang="en-US" sz="1100" dirty="0"/>
+            <a:endParaRPr lang="en-US" sz="1012" dirty="0"/>
           </a:p>
         </p:txBody>
       </p:sp>
@@ -21801,17 +21801,17 @@
         </p:nvSpPr>
         <p:spPr>
           <a:xfrm>
-            <a:off x="5242438" y="3218688"/>
-            <a:ext cx="1706819" cy="274320"/>
-          </a:xfrm>
-          <a:prstGeom prst="rect">
-            <a:avLst/>
-          </a:prstGeom>
-          <a:noFill/>
-          <a:ln/>
-        </p:spPr>
-        <p:txBody>
-          <a:bodyPr wrap="square" rtlCol="0" anchor="ctr"/>
+            <a:off x="5242438" y="3163824"/>
+            <a:ext cx="1706819" cy="189865"/>
+          </a:xfrm>
+          <a:prstGeom prst="rect">
+            <a:avLst/>
+          </a:prstGeom>
+          <a:noFill/>
+          <a:ln/>
+        </p:spPr>
+        <p:txBody>
+          <a:bodyPr wrap="square" rtlCol="0" anchor="t"/>
           <a:lstStyle/>
           <a:p>
             <a:pPr algn="ctr" indent="0" marL="0">
@@ -21840,17 +21840,17 @@
         </p:nvSpPr>
         <p:spPr>
           <a:xfrm>
-            <a:off x="5242438" y="3493008"/>
-            <a:ext cx="1706819" cy="548640"/>
-          </a:xfrm>
-          <a:prstGeom prst="rect">
-            <a:avLst/>
-          </a:prstGeom>
-          <a:noFill/>
-          <a:ln/>
-        </p:spPr>
-        <p:txBody>
-          <a:bodyPr wrap="square" rtlCol="0" anchor="ctr"/>
+            <a:off x="5242438" y="3408553"/>
+            <a:ext cx="1706819" cy="495300"/>
+          </a:xfrm>
+          <a:prstGeom prst="rect">
+            <a:avLst/>
+          </a:prstGeom>
+          <a:noFill/>
+          <a:ln/>
+        </p:spPr>
+        <p:txBody>
+          <a:bodyPr wrap="square" rtlCol="0" anchor="t"/>
           <a:lstStyle/>
           <a:p>
             <a:pPr algn="ctr" indent="0" marL="0">
@@ -21879,22 +21879,22 @@
         </p:nvSpPr>
         <p:spPr>
           <a:xfrm>
-            <a:off x="5242438" y="4114800"/>
-            <a:ext cx="1706819" cy="457200"/>
-          </a:xfrm>
-          <a:prstGeom prst="rect">
-            <a:avLst/>
-          </a:prstGeom>
-          <a:noFill/>
-          <a:ln/>
-        </p:spPr>
-        <p:txBody>
-          <a:bodyPr wrap="square" rtlCol="0" anchor="ctr"/>
+            <a:off x="5242438" y="3986149"/>
+            <a:ext cx="1706819" cy="396240"/>
+          </a:xfrm>
+          <a:prstGeom prst="rect">
+            <a:avLst/>
+          </a:prstGeom>
+          <a:noFill/>
+          <a:ln/>
+        </p:spPr>
+        <p:txBody>
+          <a:bodyPr wrap="square" rtlCol="0" anchor="t"/>
           <a:lstStyle/>
           <a:p>
             <a:pPr algn="ctr" indent="0" marL="0">
               <a:lnSpc>
-                <a:spcPct val="110000"/>
+                <a:spcPct val="105000"/>
               </a:lnSpc>
               <a:buNone/>
             </a:pPr>
@@ -21921,17 +21921,17 @@
         </p:nvSpPr>
         <p:spPr>
           <a:xfrm>
-            <a:off x="5242438" y="4645152"/>
-            <a:ext cx="1706819" cy="457200"/>
-          </a:xfrm>
-          <a:prstGeom prst="rect">
-            <a:avLst/>
-          </a:prstGeom>
-          <a:noFill/>
-          <a:ln/>
-        </p:spPr>
-        <p:txBody>
-          <a:bodyPr wrap="square" rtlCol="0" anchor="ctr"/>
+            <a:off x="5242438" y="4464685"/>
+            <a:ext cx="1706819" cy="363220"/>
+          </a:xfrm>
+          <a:prstGeom prst="rect">
+            <a:avLst/>
+          </a:prstGeom>
+          <a:noFill/>
+          <a:ln/>
+        </p:spPr>
+        <p:txBody>
+          <a:bodyPr wrap="square" rtlCol="0" anchor="t"/>
           <a:lstStyle/>
           <a:p>
             <a:pPr algn="ctr" indent="0" marL="0">
@@ -22073,24 +22073,24 @@
         </p:nvSpPr>
         <p:spPr>
           <a:xfrm>
-            <a:off x="7497897" y="3218688"/>
-            <a:ext cx="1706819" cy="274320"/>
-          </a:xfrm>
-          <a:prstGeom prst="rect">
-            <a:avLst/>
-          </a:prstGeom>
-          <a:noFill/>
-          <a:ln/>
-        </p:spPr>
-        <p:txBody>
-          <a:bodyPr wrap="square" rtlCol="0" anchor="ctr"/>
+            <a:off x="7497897" y="3163824"/>
+            <a:ext cx="1706819" cy="161385"/>
+          </a:xfrm>
+          <a:prstGeom prst="rect">
+            <a:avLst/>
+          </a:prstGeom>
+          <a:noFill/>
+          <a:ln/>
+        </p:spPr>
+        <p:txBody>
+          <a:bodyPr wrap="square" rtlCol="0" anchor="t"/>
           <a:lstStyle/>
           <a:p>
             <a:pPr algn="ctr" indent="0" marL="0">
               <a:buNone/>
             </a:pPr>
             <a:r>
-              <a:rPr lang="en-US" sz="1150" b="1" dirty="0">
+              <a:rPr lang="en-US" sz="978" b="1" dirty="0">
                 <a:solidFill>
                   <a:srgbClr val="8764B8"/>
                 </a:solidFill>
@@ -22100,7 +22100,7 @@
               </a:rPr>
               <a:t>Strategy / Account</a:t>
             </a:r>
-            <a:endParaRPr lang="en-US" sz="1150" dirty="0"/>
+            <a:endParaRPr lang="en-US" sz="978" dirty="0"/>
           </a:p>
         </p:txBody>
       </p:sp>
@@ -22112,24 +22112,24 @@
         </p:nvSpPr>
         <p:spPr>
           <a:xfrm>
-            <a:off x="7497897" y="3493008"/>
-            <a:ext cx="1706819" cy="548640"/>
-          </a:xfrm>
-          <a:prstGeom prst="rect">
-            <a:avLst/>
-          </a:prstGeom>
-          <a:noFill/>
-          <a:ln/>
-        </p:spPr>
-        <p:txBody>
-          <a:bodyPr wrap="square" rtlCol="0" anchor="ctr"/>
+            <a:off x="7497897" y="3380073"/>
+            <a:ext cx="1706819" cy="631508"/>
+          </a:xfrm>
+          <a:prstGeom prst="rect">
+            <a:avLst/>
+          </a:prstGeom>
+          <a:noFill/>
+          <a:ln/>
+        </p:spPr>
+        <p:txBody>
+          <a:bodyPr wrap="square" rtlCol="0" anchor="t"/>
           <a:lstStyle/>
           <a:p>
             <a:pPr algn="ctr" indent="0" marL="0">
               <a:buNone/>
             </a:pPr>
             <a:r>
-              <a:rPr lang="en-US" sz="1500" b="1" dirty="0">
+              <a:rPr lang="en-US" sz="1275" b="1" dirty="0">
                 <a:solidFill>
                   <a:srgbClr val="1E2235"/>
                 </a:solidFill>
@@ -22139,7 +22139,7 @@
               </a:rPr>
               <a:t>Internal &amp; External Intelligence</a:t>
             </a:r>
-            <a:endParaRPr lang="en-US" sz="1500" dirty="0"/>
+            <a:endParaRPr lang="en-US" sz="1275" dirty="0"/>
           </a:p>
         </p:txBody>
       </p:sp>
@@ -22151,27 +22151,27 @@
         </p:nvSpPr>
         <p:spPr>
           <a:xfrm>
-            <a:off x="7497897" y="4114800"/>
-            <a:ext cx="1706819" cy="457200"/>
-          </a:xfrm>
-          <a:prstGeom prst="rect">
-            <a:avLst/>
-          </a:prstGeom>
-          <a:noFill/>
-          <a:ln/>
-        </p:spPr>
-        <p:txBody>
-          <a:bodyPr wrap="square" rtlCol="0" anchor="ctr"/>
+            <a:off x="7497897" y="4093877"/>
+            <a:ext cx="1706819" cy="505206"/>
+          </a:xfrm>
+          <a:prstGeom prst="rect">
+            <a:avLst/>
+          </a:prstGeom>
+          <a:noFill/>
+          <a:ln/>
+        </p:spPr>
+        <p:txBody>
+          <a:bodyPr wrap="square" rtlCol="0" anchor="t"/>
           <a:lstStyle/>
           <a:p>
             <a:pPr algn="ctr" indent="0" marL="0">
               <a:lnSpc>
-                <a:spcPct val="110000"/>
+                <a:spcPct val="105000"/>
               </a:lnSpc>
               <a:buNone/>
             </a:pPr>
             <a:r>
-              <a:rPr lang="en-US" sz="1200" dirty="0">
+              <a:rPr lang="en-US" sz="1020" dirty="0">
                 <a:solidFill>
                   <a:srgbClr val="5B6079"/>
                 </a:solidFill>
@@ -22181,7 +22181,7 @@
               </a:rPr>
               <a:t>Enterprise Search · Deep Research · PowerPoint</a:t>
             </a:r>
-            <a:endParaRPr lang="en-US" sz="1200" dirty="0"/>
+            <a:endParaRPr lang="en-US" sz="1020" dirty="0"/>
           </a:p>
         </p:txBody>
       </p:sp>
@@ -22193,24 +22193,24 @@
         </p:nvSpPr>
         <p:spPr>
           <a:xfrm>
-            <a:off x="7497897" y="4645152"/>
-            <a:ext cx="1706819" cy="457200"/>
-          </a:xfrm>
-          <a:prstGeom prst="rect">
-            <a:avLst/>
-          </a:prstGeom>
-          <a:noFill/>
-          <a:ln/>
-        </p:spPr>
-        <p:txBody>
-          <a:bodyPr wrap="square" rtlCol="0" anchor="ctr"/>
+            <a:off x="7497897" y="4681379"/>
+            <a:ext cx="1706819" cy="308737"/>
+          </a:xfrm>
+          <a:prstGeom prst="rect">
+            <a:avLst/>
+          </a:prstGeom>
+          <a:noFill/>
+          <a:ln/>
+        </p:spPr>
+        <p:txBody>
+          <a:bodyPr wrap="square" rtlCol="0" anchor="t"/>
           <a:lstStyle/>
           <a:p>
             <a:pPr algn="ctr" indent="0" marL="0">
               <a:buNone/>
             </a:pPr>
             <a:r>
-              <a:rPr lang="en-US" sz="1100" dirty="0">
+              <a:rPr lang="en-US" sz="935" dirty="0">
                 <a:solidFill>
                   <a:srgbClr val="9AA0C0"/>
                 </a:solidFill>
@@ -22220,14 +22220,14 @@
               </a:rPr>
               <a:t>~15 min</a:t>
             </a:r>
-            <a:endParaRPr lang="en-US" sz="1100" dirty="0"/>
+            <a:endParaRPr lang="en-US" sz="935" dirty="0"/>
           </a:p>
           <a:p>
             <a:pPr algn="ctr" indent="0" marL="0">
               <a:buNone/>
             </a:pPr>
             <a:r>
-              <a:rPr lang="en-US" sz="1100" dirty="0">
+              <a:rPr lang="en-US" sz="935" dirty="0">
                 <a:solidFill>
                   <a:srgbClr val="9AA0C0"/>
                 </a:solidFill>
@@ -22237,7 +22237,7 @@
               </a:rPr>
               <a:t> ★★☆</a:t>
             </a:r>
-            <a:endParaRPr lang="en-US" sz="1100" dirty="0"/>
+            <a:endParaRPr lang="en-US" sz="935" dirty="0"/>
           </a:p>
         </p:txBody>
       </p:sp>
@@ -22345,24 +22345,24 @@
         </p:nvSpPr>
         <p:spPr>
           <a:xfrm>
-            <a:off x="9753356" y="3218688"/>
-            <a:ext cx="1706819" cy="274320"/>
-          </a:xfrm>
-          <a:prstGeom prst="rect">
-            <a:avLst/>
-          </a:prstGeom>
-          <a:noFill/>
-          <a:ln/>
-        </p:spPr>
-        <p:txBody>
-          <a:bodyPr wrap="square" rtlCol="0" anchor="ctr"/>
+            <a:off x="9753356" y="3163824"/>
+            <a:ext cx="1706819" cy="349352"/>
+          </a:xfrm>
+          <a:prstGeom prst="rect">
+            <a:avLst/>
+          </a:prstGeom>
+          <a:noFill/>
+          <a:ln/>
+        </p:spPr>
+        <p:txBody>
+          <a:bodyPr wrap="square" rtlCol="0" anchor="t"/>
           <a:lstStyle/>
           <a:p>
             <a:pPr algn="ctr" indent="0" marL="0">
               <a:buNone/>
             </a:pPr>
             <a:r>
-              <a:rPr lang="en-US" sz="1150" b="1" dirty="0">
+              <a:rPr lang="en-US" sz="1058" b="1" dirty="0">
                 <a:solidFill>
                   <a:srgbClr val="7A4DDB"/>
                 </a:solidFill>
@@ -22372,7 +22372,7 @@
               </a:rPr>
               <a:t>Knowledge work / Automation</a:t>
             </a:r>
-            <a:endParaRPr lang="en-US" sz="1150" dirty="0"/>
+            <a:endParaRPr lang="en-US" sz="1058" dirty="0"/>
           </a:p>
         </p:txBody>
       </p:sp>
@@ -22384,24 +22384,24 @@
         </p:nvSpPr>
         <p:spPr>
           <a:xfrm>
-            <a:off x="9753356" y="3493008"/>
-            <a:ext cx="1706819" cy="548640"/>
-          </a:xfrm>
-          <a:prstGeom prst="rect">
-            <a:avLst/>
-          </a:prstGeom>
-          <a:noFill/>
-          <a:ln/>
-        </p:spPr>
-        <p:txBody>
-          <a:bodyPr wrap="square" rtlCol="0" anchor="ctr"/>
+            <a:off x="9753356" y="3568040"/>
+            <a:ext cx="1706819" cy="455676"/>
+          </a:xfrm>
+          <a:prstGeom prst="rect">
+            <a:avLst/>
+          </a:prstGeom>
+          <a:noFill/>
+          <a:ln/>
+        </p:spPr>
+        <p:txBody>
+          <a:bodyPr wrap="square" rtlCol="0" anchor="t"/>
           <a:lstStyle/>
           <a:p>
             <a:pPr algn="ctr" indent="0" marL="0">
               <a:buNone/>
             </a:pPr>
             <a:r>
-              <a:rPr lang="en-US" sz="1500" b="1" dirty="0">
+              <a:rPr lang="en-US" sz="1380" b="1" dirty="0">
                 <a:solidFill>
                   <a:srgbClr val="1E2235"/>
                 </a:solidFill>
@@ -22411,7 +22411,7 @@
               </a:rPr>
               <a:t>Custom Skills &amp; Event Triggers</a:t>
             </a:r>
-            <a:endParaRPr lang="en-US" sz="1500" dirty="0"/>
+            <a:endParaRPr lang="en-US" sz="1380" dirty="0"/>
           </a:p>
         </p:txBody>
       </p:sp>
@@ -22423,27 +22423,27 @@
         </p:nvSpPr>
         <p:spPr>
           <a:xfrm>
-            <a:off x="9753356" y="4114800"/>
-            <a:ext cx="1706819" cy="457200"/>
-          </a:xfrm>
-          <a:prstGeom prst="rect">
-            <a:avLst/>
-          </a:prstGeom>
-          <a:noFill/>
-          <a:ln/>
-        </p:spPr>
-        <p:txBody>
-          <a:bodyPr wrap="square" rtlCol="0" anchor="ctr"/>
+            <a:off x="9753356" y="4106012"/>
+            <a:ext cx="1706819" cy="546811"/>
+          </a:xfrm>
+          <a:prstGeom prst="rect">
+            <a:avLst/>
+          </a:prstGeom>
+          <a:noFill/>
+          <a:ln/>
+        </p:spPr>
+        <p:txBody>
+          <a:bodyPr wrap="square" rtlCol="0" anchor="t"/>
           <a:lstStyle/>
           <a:p>
             <a:pPr algn="ctr" indent="0" marL="0">
               <a:lnSpc>
-                <a:spcPct val="110000"/>
+                <a:spcPct val="105000"/>
               </a:lnSpc>
               <a:buNone/>
             </a:pPr>
             <a:r>
-              <a:rPr lang="en-US" sz="1200" dirty="0">
+              <a:rPr lang="en-US" sz="1104" dirty="0">
                 <a:solidFill>
                   <a:srgbClr val="5B6079"/>
                 </a:solidFill>
@@ -22453,7 +22453,7 @@
               </a:rPr>
               <a:t>Custom skill · Skill Report · Event-driven task</a:t>
             </a:r>
-            <a:endParaRPr lang="en-US" sz="1200" dirty="0"/>
+            <a:endParaRPr lang="en-US" sz="1104" dirty="0"/>
           </a:p>
         </p:txBody>
       </p:sp>
@@ -22465,24 +22465,24 @@
         </p:nvSpPr>
         <p:spPr>
           <a:xfrm>
-            <a:off x="9753356" y="4645152"/>
-            <a:ext cx="1706819" cy="457200"/>
-          </a:xfrm>
-          <a:prstGeom prst="rect">
-            <a:avLst/>
-          </a:prstGeom>
-          <a:noFill/>
-          <a:ln/>
-        </p:spPr>
-        <p:txBody>
-          <a:bodyPr wrap="square" rtlCol="0" anchor="ctr"/>
+            <a:off x="9753356" y="4735119"/>
+            <a:ext cx="1706819" cy="334162"/>
+          </a:xfrm>
+          <a:prstGeom prst="rect">
+            <a:avLst/>
+          </a:prstGeom>
+          <a:noFill/>
+          <a:ln/>
+        </p:spPr>
+        <p:txBody>
+          <a:bodyPr wrap="square" rtlCol="0" anchor="t"/>
           <a:lstStyle/>
           <a:p>
             <a:pPr algn="ctr" indent="0" marL="0">
               <a:buNone/>
             </a:pPr>
             <a:r>
-              <a:rPr lang="en-US" sz="1100" dirty="0">
+              <a:rPr lang="en-US" sz="1012" dirty="0">
                 <a:solidFill>
                   <a:srgbClr val="9AA0C0"/>
                 </a:solidFill>
@@ -22492,14 +22492,14 @@
               </a:rPr>
               <a:t>~18 min</a:t>
             </a:r>
-            <a:endParaRPr lang="en-US" sz="1100" dirty="0"/>
+            <a:endParaRPr lang="en-US" sz="1012" dirty="0"/>
           </a:p>
           <a:p>
             <a:pPr algn="ctr" indent="0" marL="0">
               <a:buNone/>
             </a:pPr>
             <a:r>
-              <a:rPr lang="en-US" sz="1100" dirty="0">
+              <a:rPr lang="en-US" sz="1012" dirty="0">
                 <a:solidFill>
                   <a:srgbClr val="9AA0C0"/>
                 </a:solidFill>
@@ -22509,7 +22509,7 @@
               </a:rPr>
               <a:t> ★★☆</a:t>
             </a:r>
-            <a:endParaRPr lang="en-US" sz="1100" dirty="0"/>
+            <a:endParaRPr lang="en-US" sz="1012" dirty="0"/>
           </a:p>
         </p:txBody>
       </p:sp>
@@ -23055,7 +23055,7 @@
         <p:spPr>
           <a:xfrm>
             <a:off x="4526280" y="566928"/>
-            <a:ext cx="7132320" cy="1097280"/>
+            <a:ext cx="7132320" cy="1371600"/>
           </a:xfrm>
           <a:prstGeom prst="rect">
             <a:avLst/>
@@ -23096,7 +23096,7 @@
         </p:nvSpPr>
         <p:spPr>
           <a:xfrm>
-            <a:off x="4526280" y="1792224"/>
+            <a:off x="4526280" y="2066544"/>
             <a:ext cx="7132320" cy="365760"/>
           </a:xfrm>
           <a:prstGeom prst="rect">
@@ -23135,7 +23135,7 @@
         </p:nvSpPr>
         <p:spPr>
           <a:xfrm>
-            <a:off x="4526280" y="2295144"/>
+            <a:off x="4526280" y="2523744"/>
             <a:ext cx="457200" cy="457200"/>
           </a:xfrm>
           <a:prstGeom prst="ellipse">
@@ -23162,7 +23162,7 @@
         </p:nvSpPr>
         <p:spPr>
           <a:xfrm>
-            <a:off x="4526280" y="2295144"/>
+            <a:off x="4526280" y="2523744"/>
             <a:ext cx="457200" cy="457200"/>
           </a:xfrm>
           <a:prstGeom prst="rect">
@@ -23201,7 +23201,7 @@
         </p:nvSpPr>
         <p:spPr>
           <a:xfrm>
-            <a:off x="5166360" y="2276856"/>
+            <a:off x="5166360" y="2505456"/>
             <a:ext cx="6492240" cy="365760"/>
           </a:xfrm>
           <a:prstGeom prst="rect">
@@ -23240,7 +23240,7 @@
         </p:nvSpPr>
         <p:spPr>
           <a:xfrm>
-            <a:off x="5166360" y="2642616"/>
+            <a:off x="5166360" y="2871216"/>
             <a:ext cx="6492240" cy="502920"/>
           </a:xfrm>
           <a:prstGeom prst="rect">
@@ -23282,7 +23282,7 @@
         </p:nvSpPr>
         <p:spPr>
           <a:xfrm>
-            <a:off x="4526280" y="3264408"/>
+            <a:off x="4526280" y="3493008"/>
             <a:ext cx="457200" cy="457200"/>
           </a:xfrm>
           <a:prstGeom prst="ellipse">
@@ -23309,7 +23309,7 @@
         </p:nvSpPr>
         <p:spPr>
           <a:xfrm>
-            <a:off x="4526280" y="3264408"/>
+            <a:off x="4526280" y="3493008"/>
             <a:ext cx="457200" cy="457200"/>
           </a:xfrm>
           <a:prstGeom prst="rect">
@@ -23348,7 +23348,7 @@
         </p:nvSpPr>
         <p:spPr>
           <a:xfrm>
-            <a:off x="5166360" y="3246120"/>
+            <a:off x="5166360" y="3474720"/>
             <a:ext cx="6492240" cy="365760"/>
           </a:xfrm>
           <a:prstGeom prst="rect">
@@ -23387,7 +23387,7 @@
         </p:nvSpPr>
         <p:spPr>
           <a:xfrm>
-            <a:off x="5166360" y="3611880"/>
+            <a:off x="5166360" y="3840480"/>
             <a:ext cx="6492240" cy="502920"/>
           </a:xfrm>
           <a:prstGeom prst="rect">
@@ -23429,7 +23429,7 @@
         </p:nvSpPr>
         <p:spPr>
           <a:xfrm>
-            <a:off x="4526280" y="4233672"/>
+            <a:off x="4526280" y="4462272"/>
             <a:ext cx="457200" cy="457200"/>
           </a:xfrm>
           <a:prstGeom prst="ellipse">
@@ -23456,7 +23456,7 @@
         </p:nvSpPr>
         <p:spPr>
           <a:xfrm>
-            <a:off x="4526280" y="4233672"/>
+            <a:off x="4526280" y="4462272"/>
             <a:ext cx="457200" cy="457200"/>
           </a:xfrm>
           <a:prstGeom prst="rect">
@@ -23495,7 +23495,7 @@
         </p:nvSpPr>
         <p:spPr>
           <a:xfrm>
-            <a:off x="5166360" y="4215384"/>
+            <a:off x="5166360" y="4443984"/>
             <a:ext cx="6492240" cy="365760"/>
           </a:xfrm>
           <a:prstGeom prst="rect">
@@ -23534,7 +23534,7 @@
         </p:nvSpPr>
         <p:spPr>
           <a:xfrm>
-            <a:off x="5166360" y="4581144"/>
+            <a:off x="5166360" y="4809744"/>
             <a:ext cx="6492240" cy="502920"/>
           </a:xfrm>
           <a:prstGeom prst="rect">
@@ -23576,7 +23576,7 @@
         </p:nvSpPr>
         <p:spPr>
           <a:xfrm>
-            <a:off x="4526280" y="5202936"/>
+            <a:off x="4526280" y="5431536"/>
             <a:ext cx="457200" cy="457200"/>
           </a:xfrm>
           <a:prstGeom prst="ellipse">
@@ -23603,7 +23603,7 @@
         </p:nvSpPr>
         <p:spPr>
           <a:xfrm>
-            <a:off x="4526280" y="5202936"/>
+            <a:off x="4526280" y="5431536"/>
             <a:ext cx="457200" cy="457200"/>
           </a:xfrm>
           <a:prstGeom prst="rect">
@@ -23642,7 +23642,7 @@
         </p:nvSpPr>
         <p:spPr>
           <a:xfrm>
-            <a:off x="5166360" y="5184648"/>
+            <a:off x="5166360" y="5413248"/>
             <a:ext cx="6492240" cy="365760"/>
           </a:xfrm>
           <a:prstGeom prst="rect">
@@ -23681,7 +23681,7 @@
         </p:nvSpPr>
         <p:spPr>
           <a:xfrm>
-            <a:off x="5166360" y="5550408"/>
+            <a:off x="5166360" y="5779008"/>
             <a:ext cx="6492240" cy="502920"/>
           </a:xfrm>
           <a:prstGeom prst="rect">

</xml_diff>